<commit_message>
Shorten presentation script to fit ~9 minutes
Co-Authored-By: Claude Sonnet 5.5 <noreply@anthropic.com>
Claude-Session: https://claude.ai/code/session_011vDQkJ6MBs5BkvEmk5HUaA
</commit_message>
<xml_diff>
--- a/trabalho_analise_dados/Apresentacao_com_notas.pptx
+++ b/trabalho_analise_dados/Apresentacao_com_notas.pptx
@@ -779,7 +779,7 @@
           <a:lstStyle/>
           <a:p>
             <a:r>
-              <a:t>[8:15–8:50] Recomendo à administração quatro coisas. Não adotar o R5 como regra operacional, usando-o como hipótese de trabalho. Exigir as correções, da figura, da afirmação sobre os extremos, do V de Cramér e dos valores próprios, e análises de robustez. Encomendar um modelo para classificar novos clientes, testado em dados não usados na sua construção. E testar a retenção do cluster 3 num piloto com grupo de controlo. Em conclusão, o R5 descreve bem os clientes e mostra uma associação com o abandono, mas, na forma atual, não é uma base adequada para decidir: precisa de correções, de análises de robustez e de um modelo preditivo.</a:t>
+              <a:t>[8:15–8:50] Recomendo quatro coisas à administração. Não adotar o R5 como regra operacional, usando-o como hipótese de trabalho. Exigir as correções e análises de robustez. Encomendar um modelo para classificar novos clientes, testado em dados não usados na sua construção. E testar a retenção do cluster 3 num piloto com grupo de controlo. Em conclusão, o R5 descreve bem os clientes e mostra uma associação com o abandono, mas, na forma atual, não é uma base adequada para decidir: precisa de correções, robustez e de um modelo preditivo.</a:t>
             </a:r>
           </a:p>
         </p:txBody>
@@ -919,7 +919,7 @@
           <a:lstStyle/>
           <a:p>
             <a:r>
-              <a:t>[1:00–1:50] Avaliei o R5 segundo os três critérios do enunciado. Na adequação das opções metodológicas, a apreciação é parcial: as escolhas são razoáveis, mas sem verificar pressupostos nem testar a robustez, e há uma justificação errada. Na qualidade da análise e da interpretação, também parcial: os cálculos de base são coerentes, mas encontrei erros pontuais, uma figura inconsistente com a tabela e interpretações mais fortes do que a evidência. Na validade das conclusões e recomendações, a apreciação é insuficiente: das quatro conclusões que sustentam a decisão, só uma é suportada, e falta tratar a classificação de novos clientes. Não reproduzi a análise: recalculei os números publicados para verificar a coerência interna, e as verificações estão no anexo do relatório.</a:t>
+              <a:t>[1:00–1:50] Avaliei o R5 segundo os três critérios do enunciado. A adequação metodológica e a qualidade da análise têm apreciação parcial: as escolhas são razoáveis e os cálculos de base coerentes, mas há um erro conceptual, uma figura inconsistente e interpretações mais fortes do que a evidência. A validade das conclusões é insuficiente: das quatro que sustentam a decisão, só uma é suportada, e falta a classificação de novos clientes. Não reproduzi a análise: recalculei os números publicados, e as verificações estão no anexo.</a:t>
             </a:r>
           </a:p>
         </p:txBody>
@@ -1075,7 +1075,7 @@
           <a:lstStyle/>
           <a:p>
             <a:r>
-              <a:t>[1:50–3:15] Começando pela adequação metodológica, quatro pontos. Primeiro, os valores em falta: o analista eliminou 20 clientes, 6,7% da amostra. É aceitável pela dimensão, mas só é inofensivo se a falta de dados for aleatória, e isso não foi testado. Pelas taxas de abandono que o relatório dá por cluster, deduz-se que nesses 20 clientes há 6 abandonos, 30%, contra 15,7% nos restantes. Com o teste de Fisher, p de 0,12, não é conclusivo, mas é um sinal de alerta. Segundo, as variáveis ordinais e de contagem foram tratadas como contínuas, e o Pearson foi aplicado a variáveis assimétricas. Terceiro, e é o erro conceptual mais claro: o relatório diz que padronizar as variáveis protege o K-means dos valores extremos. Não protege. O z-score é uma transformação linear, como passar de metros para centímetros: os extremos continuam a 3,7 desvios-padrão e o K-means, que usa distâncias ao quadrado, continua sensível a eles. Quarto, quatro variáveis de valor estão correlacionadas, com r até 0,84, e por isso pesam mais na distância; e o relatório não indica inicializações nem semente, o que impede reproduzir a análise.</a:t>
+              <a:t>[1:50–3:15] Na adequação metodológica, quatro pontos. Primeiro, o analista eliminou 20 clientes com valores em falta. É aceitável, mas só é inofensivo se a falta for aleatória, e isso não foi testado. Pelas taxas de abandono por cluster deduz-se que nesses 20 há 6 abandonos, 30%, contra 15,7% nos restantes; com p de 0,12 não é conclusivo, mas é um alerta. Segundo, ordinais e contagens foram tratadas como contínuas. Terceiro, o erro mais claro: o relatório diz que padronizar protege o K-means dos valores extremos. Não protege. O z-score é linear, como passar de metros para centímetros: os extremos continuam a 3,7 desvios-padrão e o K-means continua sensível a eles. Quarto, quatro variáveis de valor correlacionadas, com r até 0,84, pesam mais na distância, e não há inicializações nem semente, pelo que a análise não é reprodutível.</a:t>
             </a:r>
           </a:p>
         </p:txBody>
@@ -1145,7 +1145,7 @@
           <a:lstStyle/>
           <a:p>
             <a:r>
-              <a:t>[3:15–4:10] Na escolha do número de clusters, o coeficiente de silhueta é máximo com k igual a 2, 0,353, e o analista escolheu k igual a 3, 0,325, por ser mais interpretável. Escolher pelo negócio é legítimo, e o analista foi transparente. Mas usou um só índice, sem análise de estabilidade, e, como se vê no gráfico, todas as silhuetas ficam entre 0,21 e 0,35, o que indica estrutura fraca. Com k igual a 4 o valor é quase igual, 0,319, e a própria figura do relatório sugere quatro nuvens. Por isso, dizer que os segmentos são distintos é demasiado forte para os dados.</a:t>
+              <a:t>[3:15–4:10] A silhueta é máxima com k igual a 2, 0,353, e o analista escolheu k igual a 3, 0,325, por ser mais interpretável. É legítimo e foi transparente, mas usou um só índice, sem estabilidade, e todas as silhuetas ficam entre 0,21 e 0,35, estrutura fraca. Com k igual a 4 o valor é quase igual, e a figura do relatório sugere quatro nuvens. Por isso, dizer que os segmentos são distintos é demasiado forte.</a:t>
             </a:r>
           </a:p>
         </p:txBody>
@@ -1215,7 +1215,7 @@
           <a:lstStyle/>
           <a:p>
             <a:r>
-              <a:t>[4:10–5:20] Quanto à qualidade da análise, encontrei erros verificáveis. O V de Cramér da Região está errado: a raiz de 1,364 a dividir por 300 dá 0,067 e não 0,039; as outras sete linhas da tabela batem certo. Os valores próprios somam 9,033, quando numa PCA com nove variáveis deviam somar 9. As loadings da Tabela 7 são, na verdade, vetores próprios. E o cluster 3 é descrito como mais velho, mas tem 47,9 anos, praticamente igual ao cluster 1, com 47,2. O problema mais grave está na figura do relatório, aqui anotada. O cluster 3, a verde, está no lado direito da primeira componente, ou seja, com rendimento, despesa e visitas elevados, mas a Tabela 10 atribui esse perfil ao cluster 1. As proporções de pontos, cerca de 22, 48 e 30 por cento, indicam que as legendas dos clusters 1 e 3 estão trocadas, na figura ou na tabela. Quem lesse a figura podia dirigir a retenção ao segmento errado.</a:t>
+              <a:t>[4:10–5:20] Na qualidade da análise, encontrei erros verificáveis. O V de Cramér da Região está errado: a raiz de 1,364 sobre 300 dá 0,067 e não 0,039. Os valores próprios somam 9,033 em vez de 9. As loadings são, na verdade, vetores próprios. E o cluster 3 é descrito como mais velho, mas tem 47,9 anos, como o cluster 1. O mais grave está na figura: o cluster 3, a verde, está no lado direito da primeira componente, com rendimento e despesa elevados, mas a Tabela 10 atribui esse perfil ao cluster 1. As proporções de pontos, 22, 48 e 30 por cento, indicam que as legendas dos clusters 1 e 3 estão trocadas, na figura ou na tabela. Quem lesse a figura podia dirigir a retenção ao segmento errado.</a:t>
             </a:r>
           </a:p>
         </p:txBody>
@@ -1285,7 +1285,7 @@
           <a:lstStyle/>
           <a:p>
             <a:r>
-              <a:t>[5:20–6:15] Há ainda interpretações que vão além da evidência. O valor do cliente é inferido do rendimento e da despesa, que não medem o valor para a empresa; seria preciso receita ou margem. Os clusters são descritos com as mesmas variáveis que os formaram, por isso as diferenças são grandes por construção, e só se apresentam médias, sem dispersão. O método de pagamento, com p de 0,065, não é significativo, mas o relatório diz que pode ser um fator relevante para a retenção, enquanto a fidelização e o perfil, com p de 0,088 e 0,090, não recebem o mesmo tratamento. É uma hipótese a testar, não uma conclusão. Por fim, os rótulos valor e modernização dos componentes são leituras, e a interpretação é seletiva.</a:t>
+              <a:t>[5:20–6:15] Há interpretações que vão além da evidência. O valor do cliente é inferido do rendimento e da despesa, que não medem o valor para a empresa. Os clusters são descritos com as variáveis que os formaram, por isso as diferenças são grandes por construção. E o método de pagamento, com p de 0,065, não é significativo, mas é apresentado como fator relevante, enquanto a fidelização e o perfil, com p de 0,088 e 0,090, são ignorados. É uma hipótese a testar, não uma conclusão.</a:t>
             </a:r>
           </a:p>
         </p:txBody>
@@ -1355,7 +1355,7 @@
           <a:lstStyle/>
           <a:p>
             <a:r>
-              <a:t>[6:15–7:25] Passando à validade das conclusões, analisei as quatro que sustentam a decisão. A existência de três segmentos distintos é só parcialmente suportada, pelas razões que vimos. A única suportada é que o cluster 3 tem maior abandono, 23% contra 8,1% e 9,6%, com p de 0,0055; refiz o teste e confirma-se. Mas é uma associação, não uma previsão: 77% dos clientes do cluster 3 não abandonaram, não há sensibilidade nem AUC, os intervalos de confiança do cluster 3 e do cluster 1 sobrepõem-se um pouco, como se vê no gráfico, e não se sabe quando foram medidas as variáveis, que podem refletir o próprio abandono. Por isso, demonstra devia ser sugere. As duas últimas conclusões não têm suporte: as diferenças entre clusters em variáveis categóricas não têm tabela nem teste, e o método de pagamento não é significativo.</a:t>
+              <a:t>[6:15–7:25] Na validade das conclusões, analisei as quatro que sustentam a decisão. Três segmentos distintos: parcialmente suportada. A única suportada é que o cluster 3 tem maior abandono, 23% contra 8,1% e 9,6%, com p de 0,0055, que confirmei. Mas é associação, não previsão: 77% do cluster 3 não abandonou, não há AUC, os intervalos de confiança sobrepõem-se um pouco, como se vê no gráfico, e não se sabe quando foram medidas as variáveis. Por isso, demonstra devia ser sugere. As outras duas, diferenças entre clusters em variáveis categóricas e método de pagamento como fator de retenção, não têm suporte.</a:t>
             </a:r>
           </a:p>
         </p:txBody>
@@ -1425,7 +1425,7 @@
           <a:lstStyle/>
           <a:p>
             <a:r>
-              <a:t>[7:25–8:15] [ATENÇÃO: este slide está repetido do anterior. Substitui-o pelo quadro «Os resultados respondem ao problema da empresa?» e usa este texto.] Voltando ao problema da empresa. Conhecer o perfil dos clientes: em grande parte sim, com reservas por causa dos dados em falta e dos extremos não tratados. Identificar segmentos distintos: só parcialmente, porque a estrutura é fraca e faltam validações. E classificar novos clientes: não. O relatório não apresenta centróides nem parâmetros de padronização, nenhum classificador, nenhuma validação, e a eliminação de casos não se pode aplicar a novos clientes. Além disso, as variáveis usadas, como antiguidade, visitas ou reclamações, acumulam-se com o tempo e não existem à entrada: um cliente recém-chegado tenderia a parecer-se com o cluster 2 só por ser recente, o que é uma inferência minha, não um cálculo. E, com 50 abandonos, a amostra limita modelos mais complexos.</a:t>
+              <a:t>[7:25–8:15] [ATENÇÃO: este slide está repetido do anterior. Substitui-o pelo quadro «Os resultados respondem ao problema da empresa?» e usa este texto.] Quanto ao problema da empresa: o perfil dos clientes, em grande parte, com reservas; os segmentos distintos, só parcialmente; e classificar novos clientes, não. Não há centróides nem parâmetros de padronização, classificador ou validação, e a eliminação de casos não se aplica a clientes novos. Além disso, as variáveis usadas, como antiguidade ou visitas, acumulam-se com o tempo e não existem à entrada: um cliente recém-chegado tenderia a parecer-se com o cluster 2 só por ser recente, o que é uma inferência minha, não um cálculo.</a:t>
             </a:r>
           </a:p>
         </p:txBody>

</xml_diff>

<commit_message>
Update presentation script and notes to the revised deck
Co-Authored-By: Claude Sonnet 5.5 <noreply@anthropic.com>
Claude-Session: https://claude.ai/code/session_011vDQkJ6MBs5BkvEmk5HUaA
</commit_message>
<xml_diff>
--- a/trabalho_analise_dados/Apresentacao_com_notas.pptx
+++ b/trabalho_analise_dados/Apresentacao_com_notas.pptx
@@ -1425,7 +1425,7 @@
           <a:lstStyle/>
           <a:p>
             <a:r>
-              <a:t>[7:25–8:15] [ATENÇÃO: este slide está repetido do anterior. Substitui-o pelo quadro «Os resultados respondem ao problema da empresa?» e usa este texto.] Quanto ao problema da empresa: o perfil dos clientes, em grande parte, com reservas; os segmentos distintos, só parcialmente; e classificar novos clientes, não. Não há centróides nem parâmetros de padronização, classificador ou validação, e a eliminação de casos não se aplica a clientes novos. Além disso, as variáveis usadas, como antiguidade ou visitas, acumulam-se com o tempo e não existem à entrada: um cliente recém-chegado tenderia a parecer-se com o cluster 2 só por ser recente, o que é uma inferência minha, não um cálculo.</a:t>
+              <a:t>[7:25–8:15] Quanto ao problema da empresa: o perfil dos clientes, em grande parte, com reservas; os segmentos distintos, só parcialmente; e classificar novos clientes, não. Não há centróides nem parâmetros de padronização, classificador ou validação, e a eliminação de casos não se aplica a clientes novos. Além disso, as variáveis usadas, como antiguidade ou visitas, acumulam-se com o tempo e não existem à entrada: um cliente recém-chegado tenderia a parecer-se com o cluster 2 só por ser recente, o que é uma inferência minha, não um cálculo.</a:t>
             </a:r>
           </a:p>
         </p:txBody>
@@ -4060,6 +4060,46 @@
           </a:p>
         </p:txBody>
       </p:sp>
+      <p:sp>
+        <p:nvSpPr>
+          <p:cNvPr id="6" name="TextBox 5">
+            <a:extLst>
+              <a:ext uri="{FF2B5EF4-FFF2-40B4-BE49-F238E27FC236}">
+                <a16:creationId xmlns:a16="http://schemas.microsoft.com/office/drawing/2014/main" id="{21EF060C-1CA7-7CE1-895E-BAF391FA1CE1}"/>
+              </a:ext>
+            </a:extLst>
+          </p:cNvPr>
+          <p:cNvSpPr txBox="1"/>
+          <p:nvPr/>
+        </p:nvSpPr>
+        <p:spPr>
+          <a:xfrm>
+            <a:off x="1783080" y="4382405"/>
+            <a:ext cx="8686800" cy="769441"/>
+          </a:xfrm>
+          <a:prstGeom prst="rect">
+            <a:avLst/>
+          </a:prstGeom>
+          <a:noFill/>
+        </p:spPr>
+        <p:txBody>
+          <a:bodyPr wrap="square">
+            <a:spAutoFit/>
+          </a:bodyPr>
+          <a:lstStyle/>
+          <a:p>
+            <a:r>
+              <a:rPr lang="pt-BR" sz="2200" b="1" dirty="0">
+                <a:solidFill>
+                  <a:srgbClr val="E83342"/>
+                </a:solidFill>
+                <a:latin typeface="Calibri"/>
+              </a:rPr>
+              <a:t>Conclusão: bom ponto de partida, mas ainda não uma base adequada. Precisa de correções, robustez e de um modelo preditivo.</a:t>
+            </a:r>
+          </a:p>
+        </p:txBody>
+      </p:sp>
     </p:spTree>
     <p:extLst>
       <p:ext uri="{BB962C8B-B14F-4D97-AF65-F5344CB8AC3E}">
@@ -4289,6 +4329,46 @@
                 <a:latin typeface="Calibri"/>
               </a:rPr>
               <a:t>Os resultados e conclusões do analista constituem uma base adequada para apoiar a segmentação e a classificação de novos clientes?</a:t>
+            </a:r>
+          </a:p>
+        </p:txBody>
+      </p:sp>
+      <p:sp>
+        <p:nvSpPr>
+          <p:cNvPr id="5" name="TextBox 4">
+            <a:extLst>
+              <a:ext uri="{FF2B5EF4-FFF2-40B4-BE49-F238E27FC236}">
+                <a16:creationId xmlns:a16="http://schemas.microsoft.com/office/drawing/2014/main" id="{93C92377-8B1F-47B0-45FC-FEF7E14B6C0B}"/>
+              </a:ext>
+            </a:extLst>
+          </p:cNvPr>
+          <p:cNvSpPr txBox="1"/>
+          <p:nvPr/>
+        </p:nvSpPr>
+        <p:spPr>
+          <a:xfrm>
+            <a:off x="651322" y="3429000"/>
+            <a:ext cx="10833106" cy="769441"/>
+          </a:xfrm>
+          <a:prstGeom prst="rect">
+            <a:avLst/>
+          </a:prstGeom>
+          <a:noFill/>
+        </p:spPr>
+        <p:txBody>
+          <a:bodyPr wrap="square">
+            <a:spAutoFit/>
+          </a:bodyPr>
+          <a:lstStyle/>
+          <a:p>
+            <a:r>
+              <a:rPr lang="pt-BR" sz="2200" b="1" dirty="0">
+                <a:solidFill>
+                  <a:srgbClr val="FF0000"/>
+                </a:solidFill>
+                <a:latin typeface="Calibri"/>
+              </a:rPr>
+              <a:t>Resposta: ainda não. Bom ponto de partida, mas faltam validação, correções e a classificação de novos clientes.</a:t>
             </a:r>
           </a:p>
         </p:txBody>
@@ -4537,7 +4617,7 @@
         <p:spPr>
           <a:xfrm>
             <a:off x="609600" y="1577340"/>
-            <a:ext cx="10972800" cy="2277547"/>
+            <a:ext cx="10972800" cy="4137660"/>
           </a:xfrm>
         </p:spPr>
         <p:txBody>
@@ -4555,7 +4635,15 @@
                   <a:srgbClr val="1D1D1F"/>
                 </a:solidFill>
               </a:rPr>
-              <a:t>• Eliminação de 20 clientes (6,7%): só inócua se a falta for aleatória; 6 abandonos nesses 20 (30%) vs 15,7% (Fisher p ≈ 0,12: sinal, não prova)</a:t>
+              <a:t>• </a:t>
+            </a:r>
+            <a:r>
+              <a:rPr lang="pt-BR" sz="2400" dirty="0">
+                <a:solidFill>
+                  <a:srgbClr val="1D1D1F"/>
+                </a:solidFill>
+              </a:rPr>
+              <a:t>Eliminação de 20 clientes (6,7%): só inócua se a falta for aleatória; 6 abandonos nesses 20 (30%) vs 15,7% (Fisher p ≈ 0,12: sinal, não prova)</a:t>
             </a:r>
           </a:p>
           <a:p>
@@ -4565,7 +4653,7 @@
               </a:spcAft>
             </a:pPr>
             <a:r>
-              <a:rPr lang="pt-BR" dirty="0">
+              <a:rPr lang="pt-BR" sz="2400" dirty="0">
                 <a:solidFill>
                   <a:srgbClr val="1D1D1F"/>
                 </a:solidFill>
@@ -4580,7 +4668,7 @@
               </a:spcAft>
             </a:pPr>
             <a:r>
-              <a:rPr lang="pt-BR" dirty="0">
+              <a:rPr lang="pt-BR" sz="2400" dirty="0">
                 <a:solidFill>
                   <a:srgbClr val="1D1D1F"/>
                 </a:solidFill>
@@ -4595,7 +4683,7 @@
               </a:spcAft>
             </a:pPr>
             <a:r>
-              <a:rPr lang="pt-BR" dirty="0">
+              <a:rPr lang="pt-BR" sz="2400" dirty="0">
                 <a:solidFill>
                   <a:srgbClr val="1D1D1F"/>
                 </a:solidFill>
@@ -7011,7 +7099,7 @@
           <a:bodyPr/>
           <a:lstStyle/>
           <a:p>
-            <a:endParaRPr lang="en-GB"/>
+            <a:endParaRPr lang="en-GB" dirty="0"/>
           </a:p>
         </p:txBody>
       </p:sp>
@@ -7030,7 +7118,7 @@
         <p:spPr>
           <a:xfrm>
             <a:off x="548640" y="411480"/>
-            <a:ext cx="11155680" cy="822960"/>
+            <a:ext cx="11155680" cy="584775"/>
           </a:xfrm>
           <a:prstGeom prst="rect">
             <a:avLst/>
@@ -7044,23 +7132,23 @@
           <a:lstStyle/>
           <a:p>
             <a:r>
-              <a:rPr sz="3200" b="1">
+              <a:rPr lang="pt-BR" sz="3200" b="1" dirty="0">
                 <a:solidFill>
                   <a:srgbClr val="E83342"/>
                 </a:solidFill>
                 <a:latin typeface="Calibri"/>
               </a:rPr>
-              <a:t>Critério C: validade das conclusões</a:t>
+              <a:t>Os resultados respondem ao problema da empresa?</a:t>
             </a:r>
           </a:p>
         </p:txBody>
       </p:sp>
       <p:graphicFrame>
         <p:nvGraphicFramePr>
-          <p:cNvPr id="7" name="Table 6">
+          <p:cNvPr id="11" name="Table 10">
             <a:extLst>
               <a:ext uri="{FF2B5EF4-FFF2-40B4-BE49-F238E27FC236}">
-                <a16:creationId xmlns:a16="http://schemas.microsoft.com/office/drawing/2014/main" id="{41FAF367-5DC7-2A7A-D245-7451CCA4E3B0}"/>
+                <a16:creationId xmlns:a16="http://schemas.microsoft.com/office/drawing/2014/main" id="{5AD0356A-0BA8-F1B9-5F44-7C5105BFDD64}"/>
               </a:ext>
             </a:extLst>
           </p:cNvPr>
@@ -7071,7 +7159,7 @@
         </p:nvGraphicFramePr>
         <p:xfrm>
           <a:off x="548640" y="1737360"/>
-          <a:ext cx="6583680" cy="3429000"/>
+          <a:ext cx="11064240" cy="3657600"/>
         </p:xfrm>
         <a:graphic>
           <a:graphicData uri="http://schemas.openxmlformats.org/drawingml/2006/table">
@@ -7080,7 +7168,7 @@
                 <a:tableStyleId>{5C22544A-7EE6-4342-B048-85BDC9FD1C3A}</a:tableStyleId>
               </a:tblPr>
               <a:tblGrid>
-                <a:gridCol w="4572000">
+                <a:gridCol w="3840480">
                   <a:extLst>
                     <a:ext uri="{9D8B030D-6E8A-4147-A177-3AD203B41FA5}">
                       <a16:colId xmlns:a16="http://schemas.microsoft.com/office/drawing/2014/main" val="20000"/>
@@ -7094,18 +7182,61 @@
                     </a:ext>
                   </a:extLst>
                 </a:gridCol>
+                <a:gridCol w="5212080">
+                  <a:extLst>
+                    <a:ext uri="{9D8B030D-6E8A-4147-A177-3AD203B41FA5}">
+                      <a16:colId xmlns:a16="http://schemas.microsoft.com/office/drawing/2014/main" val="20002"/>
+                    </a:ext>
+                  </a:extLst>
+                </a:gridCol>
               </a:tblGrid>
-              <a:tr h="685800">
+              <a:tr h="914400">
                 <a:tc>
                   <a:txBody>
                     <a:bodyPr/>
                     <a:lstStyle/>
                     <a:p>
                       <a:r>
-                        <a:rPr sz="1600" b="1">
+                        <a:rPr sz="1800" b="1" dirty="0" err="1">
                           <a:latin typeface="Calibri"/>
                         </a:rPr>
-                        <a:t>Conclusão do R5</a:t>
+                        <a:t>Objetivo</a:t>
+                      </a:r>
+                      <a:r>
+                        <a:rPr sz="1800" b="1" dirty="0">
+                          <a:latin typeface="Calibri"/>
+                        </a:rPr>
+                        <a:t> da </a:t>
+                      </a:r>
+                      <a:r>
+                        <a:rPr sz="1800" b="1" dirty="0" err="1">
+                          <a:latin typeface="Calibri"/>
+                        </a:rPr>
+                        <a:t>empresa</a:t>
+                      </a:r>
+                      <a:endParaRPr sz="1800" b="1" dirty="0">
+                        <a:latin typeface="Calibri"/>
+                      </a:endParaRPr>
+                    </a:p>
+                  </a:txBody>
+                  <a:tcPr/>
+                </a:tc>
+                <a:tc>
+                  <a:txBody>
+                    <a:bodyPr/>
+                    <a:lstStyle/>
+                    <a:p>
+                      <a:r>
+                        <a:rPr sz="1800" b="1" dirty="0" err="1">
+                          <a:latin typeface="Calibri"/>
+                        </a:rPr>
+                        <a:t>Cumpre</a:t>
+                      </a:r>
+                      <a:r>
+                        <a:rPr sz="1800" b="1" dirty="0">
+                          <a:latin typeface="Calibri"/>
+                        </a:rPr>
+                        <a:t>?</a:t>
                       </a:r>
                     </a:p>
                   </a:txBody>
@@ -7117,10 +7248,10 @@
                     <a:lstStyle/>
                     <a:p>
                       <a:r>
-                        <a:rPr sz="1600" b="1">
+                        <a:rPr sz="1800" b="1">
                           <a:latin typeface="Calibri"/>
                         </a:rPr>
-                        <a:t>Suportada?</a:t>
+                        <a:t>Porquê</a:t>
                       </a:r>
                     </a:p>
                   </a:txBody>
@@ -7132,17 +7263,59 @@
                   </a:ext>
                 </a:extLst>
               </a:tr>
-              <a:tr h="685800">
+              <a:tr h="914400">
                 <a:tc>
                   <a:txBody>
                     <a:bodyPr/>
                     <a:lstStyle/>
                     <a:p>
                       <a:r>
-                        <a:rPr sz="1600" b="0">
+                        <a:rPr sz="1800" b="0" dirty="0" err="1">
                           <a:latin typeface="Calibri"/>
                         </a:rPr>
-                        <a:t>Existem 3 segmentos distintos</a:t>
+                        <a:t>Compreender</a:t>
+                      </a:r>
+                      <a:r>
+                        <a:rPr sz="1800" b="0" dirty="0">
+                          <a:latin typeface="Calibri"/>
+                        </a:rPr>
+                        <a:t> o </a:t>
+                      </a:r>
+                      <a:r>
+                        <a:rPr sz="1800" b="0" dirty="0" err="1">
+                          <a:latin typeface="Calibri"/>
+                        </a:rPr>
+                        <a:t>perfil</a:t>
+                      </a:r>
+                      <a:r>
+                        <a:rPr sz="1800" b="0" dirty="0">
+                          <a:latin typeface="Calibri"/>
+                        </a:rPr>
+                        <a:t> dos </a:t>
+                      </a:r>
+                      <a:r>
+                        <a:rPr sz="1800" b="0" dirty="0" err="1">
+                          <a:latin typeface="Calibri"/>
+                        </a:rPr>
+                        <a:t>clientes</a:t>
+                      </a:r>
+                      <a:endParaRPr sz="1800" b="0" dirty="0">
+                        <a:latin typeface="Calibri"/>
+                      </a:endParaRPr>
+                    </a:p>
+                  </a:txBody>
+                  <a:tcPr/>
+                </a:tc>
+                <a:tc>
+                  <a:txBody>
+                    <a:bodyPr/>
+                    <a:lstStyle/>
+                    <a:p>
+                      <a:r>
+                        <a:rPr sz="1800" b="0">
+                          <a:latin typeface="Calibri"/>
+                        </a:rPr>
+                        <a:t>Em grande parte</a:t>
                       </a:r>
                     </a:p>
                   </a:txBody>
@@ -7154,10 +7327,10 @@
                     <a:lstStyle/>
                     <a:p>
                       <a:r>
-                        <a:rPr sz="1600" b="0">
+                        <a:rPr sz="1800" b="0">
                           <a:latin typeface="Calibri"/>
                         </a:rPr>
-                        <a:t>Parcialmente</a:t>
+                        <a:t>Descrição clara, com reservas (dados em falta, extremos)</a:t>
                       </a:r>
                     </a:p>
                   </a:txBody>
@@ -7169,53 +7342,17 @@
                   </a:ext>
                 </a:extLst>
               </a:tr>
-              <a:tr h="685800">
+              <a:tr h="914400">
                 <a:tc>
                   <a:txBody>
                     <a:bodyPr/>
                     <a:lstStyle/>
                     <a:p>
                       <a:r>
-                        <a:rPr sz="1600" b="0" dirty="0">
+                        <a:rPr sz="1800" b="0">
                           <a:latin typeface="Calibri"/>
                         </a:rPr>
-                        <a:t>O Cluster 3 </a:t>
-                      </a:r>
-                      <a:r>
-                        <a:rPr sz="1600" b="0" dirty="0" err="1">
-                          <a:latin typeface="Calibri"/>
-                        </a:rPr>
-                        <a:t>tem</a:t>
-                      </a:r>
-                      <a:r>
-                        <a:rPr sz="1600" b="0" dirty="0">
-                          <a:latin typeface="Calibri"/>
-                        </a:rPr>
-                        <a:t> </a:t>
-                      </a:r>
-                      <a:r>
-                        <a:rPr sz="1600" b="0" dirty="0" err="1">
-                          <a:latin typeface="Calibri"/>
-                        </a:rPr>
-                        <a:t>maior</a:t>
-                      </a:r>
-                      <a:r>
-                        <a:rPr sz="1600" b="0" dirty="0">
-                          <a:latin typeface="Calibri"/>
-                        </a:rPr>
-                        <a:t> </a:t>
-                      </a:r>
-                      <a:r>
-                        <a:rPr sz="1600" b="0" dirty="0" err="1">
-                          <a:latin typeface="Calibri"/>
-                        </a:rPr>
-                        <a:t>abandono</a:t>
-                      </a:r>
-                      <a:r>
-                        <a:rPr sz="1600" b="0" dirty="0">
-                          <a:latin typeface="Calibri"/>
-                        </a:rPr>
-                        <a:t> (23,0% vs 8,1% e 9,6%)</a:t>
+                        <a:t>Identificar segmentos distintos</a:t>
                       </a:r>
                     </a:p>
                   </a:txBody>
@@ -7227,32 +7364,10 @@
                     <a:lstStyle/>
                     <a:p>
                       <a:r>
-                        <a:rPr sz="1600" b="0">
+                        <a:rPr sz="1800" b="0">
                           <a:latin typeface="Calibri"/>
                         </a:rPr>
-                        <a:t>Sim, como associação</a:t>
-                      </a:r>
-                    </a:p>
-                  </a:txBody>
-                  <a:tcPr/>
-                </a:tc>
-                <a:extLst>
-                  <a:ext uri="{0D108BD9-81ED-4DB2-BD59-A6C34878D82A}">
-                    <a16:rowId xmlns:a16="http://schemas.microsoft.com/office/drawing/2014/main" val="10002"/>
-                  </a:ext>
-                </a:extLst>
-              </a:tr>
-              <a:tr h="685800">
-                <a:tc>
-                  <a:txBody>
-                    <a:bodyPr/>
-                    <a:lstStyle/>
-                    <a:p>
-                      <a:r>
-                        <a:rPr sz="1600" b="0">
-                          <a:latin typeface="Calibri"/>
-                        </a:rPr>
-                        <a:t>Diferenças entre clusters em grupo etário, plano e pagamento</a:t>
+                        <a:t>Não totalmente</a:t>
                       </a:r>
                     </a:p>
                   </a:txBody>
@@ -7264,10 +7379,212 @@
                     <a:lstStyle/>
                     <a:p>
                       <a:r>
-                        <a:rPr sz="1600" b="0">
+                        <a:rPr sz="1800" b="0" dirty="0" err="1">
                           <a:latin typeface="Calibri"/>
                         </a:rPr>
-                        <a:t>Sem suporte</a:t>
+                        <a:t>Estrutura</a:t>
+                      </a:r>
+                      <a:r>
+                        <a:rPr sz="1800" b="0" dirty="0">
+                          <a:latin typeface="Calibri"/>
+                        </a:rPr>
+                        <a:t> </a:t>
+                      </a:r>
+                      <a:r>
+                        <a:rPr sz="1800" b="0" dirty="0" err="1">
+                          <a:latin typeface="Calibri"/>
+                        </a:rPr>
+                        <a:t>fraca</a:t>
+                      </a:r>
+                      <a:r>
+                        <a:rPr sz="1800" b="0" dirty="0">
+                          <a:latin typeface="Calibri"/>
+                        </a:rPr>
+                        <a:t>; k e </a:t>
+                      </a:r>
+                      <a:r>
+                        <a:rPr sz="1800" b="0" dirty="0" err="1">
+                          <a:latin typeface="Calibri"/>
+                        </a:rPr>
+                        <a:t>extremos</a:t>
+                      </a:r>
+                      <a:r>
+                        <a:rPr sz="1800" b="0" dirty="0">
+                          <a:latin typeface="Calibri"/>
+                        </a:rPr>
+                        <a:t> </a:t>
+                      </a:r>
+                      <a:r>
+                        <a:rPr sz="1800" b="0" dirty="0" err="1">
+                          <a:latin typeface="Calibri"/>
+                        </a:rPr>
+                        <a:t>por</a:t>
+                      </a:r>
+                      <a:r>
+                        <a:rPr sz="1800" b="0" dirty="0">
+                          <a:latin typeface="Calibri"/>
+                        </a:rPr>
+                        <a:t> </a:t>
+                      </a:r>
+                      <a:r>
+                        <a:rPr sz="1800" b="0" dirty="0" err="1">
+                          <a:latin typeface="Calibri"/>
+                        </a:rPr>
+                        <a:t>validar</a:t>
+                      </a:r>
+                      <a:endParaRPr sz="1800" b="0" dirty="0">
+                        <a:latin typeface="Calibri"/>
+                      </a:endParaRPr>
+                    </a:p>
+                  </a:txBody>
+                  <a:tcPr/>
+                </a:tc>
+                <a:extLst>
+                  <a:ext uri="{0D108BD9-81ED-4DB2-BD59-A6C34878D82A}">
+                    <a16:rowId xmlns:a16="http://schemas.microsoft.com/office/drawing/2014/main" val="10002"/>
+                  </a:ext>
+                </a:extLst>
+              </a:tr>
+              <a:tr h="914400">
+                <a:tc>
+                  <a:txBody>
+                    <a:bodyPr/>
+                    <a:lstStyle/>
+                    <a:p>
+                      <a:r>
+                        <a:rPr sz="1800" b="0">
+                          <a:latin typeface="Calibri"/>
+                        </a:rPr>
+                        <a:t>Sistema para classificar novos clientes</a:t>
+                      </a:r>
+                    </a:p>
+                  </a:txBody>
+                  <a:tcPr/>
+                </a:tc>
+                <a:tc>
+                  <a:txBody>
+                    <a:bodyPr/>
+                    <a:lstStyle/>
+                    <a:p>
+                      <a:r>
+                        <a:rPr sz="1800" b="0" dirty="0" err="1">
+                          <a:latin typeface="Calibri"/>
+                        </a:rPr>
+                        <a:t>Não</a:t>
+                      </a:r>
+                      <a:endParaRPr sz="1800" b="0" dirty="0">
+                        <a:latin typeface="Calibri"/>
+                      </a:endParaRPr>
+                    </a:p>
+                  </a:txBody>
+                  <a:tcPr/>
+                </a:tc>
+                <a:tc>
+                  <a:txBody>
+                    <a:bodyPr/>
+                    <a:lstStyle/>
+                    <a:p>
+                      <a:r>
+                        <a:rPr sz="1800" b="0" dirty="0">
+                          <a:latin typeface="Calibri"/>
+                        </a:rPr>
+                        <a:t>Sem </a:t>
+                      </a:r>
+                      <a:r>
+                        <a:rPr sz="1800" b="0" dirty="0" err="1">
+                          <a:latin typeface="Calibri"/>
+                        </a:rPr>
+                        <a:t>regra</a:t>
+                      </a:r>
+                      <a:r>
+                        <a:rPr sz="1800" b="0" dirty="0">
+                          <a:latin typeface="Calibri"/>
+                        </a:rPr>
+                        <a:t> de </a:t>
+                      </a:r>
+                      <a:r>
+                        <a:rPr sz="1800" b="0" dirty="0" err="1">
+                          <a:latin typeface="Calibri"/>
+                        </a:rPr>
+                        <a:t>atribuição</a:t>
+                      </a:r>
+                      <a:r>
+                        <a:rPr sz="1800" b="0" dirty="0">
+                          <a:latin typeface="Calibri"/>
+                        </a:rPr>
+                        <a:t>, </a:t>
+                      </a:r>
+                      <a:r>
+                        <a:rPr sz="1800" b="0" dirty="0" err="1">
+                          <a:latin typeface="Calibri"/>
+                        </a:rPr>
+                        <a:t>classificador</a:t>
+                      </a:r>
+                      <a:r>
+                        <a:rPr sz="1800" b="0" dirty="0">
+                          <a:latin typeface="Calibri"/>
+                        </a:rPr>
+                        <a:t> </a:t>
+                      </a:r>
+                      <a:r>
+                        <a:rPr sz="1800" b="0" dirty="0" err="1">
+                          <a:latin typeface="Calibri"/>
+                        </a:rPr>
+                        <a:t>ou</a:t>
+                      </a:r>
+                      <a:r>
+                        <a:rPr sz="1800" b="0" dirty="0">
+                          <a:latin typeface="Calibri"/>
+                        </a:rPr>
+                        <a:t> </a:t>
+                      </a:r>
+                      <a:r>
+                        <a:rPr sz="1800" b="0" dirty="0" err="1">
+                          <a:latin typeface="Calibri"/>
+                        </a:rPr>
+                        <a:t>validação</a:t>
+                      </a:r>
+                      <a:r>
+                        <a:rPr sz="1800" b="0" dirty="0">
+                          <a:latin typeface="Calibri"/>
+                        </a:rPr>
+                        <a:t>; </a:t>
+                      </a:r>
+                      <a:r>
+                        <a:rPr sz="1800" b="0" dirty="0" err="1">
+                          <a:latin typeface="Calibri"/>
+                        </a:rPr>
+                        <a:t>variáveis</a:t>
+                      </a:r>
+                      <a:r>
+                        <a:rPr sz="1800" b="0" dirty="0">
+                          <a:latin typeface="Calibri"/>
+                        </a:rPr>
+                        <a:t> </a:t>
+                      </a:r>
+                      <a:r>
+                        <a:rPr sz="1800" b="0" dirty="0" err="1">
+                          <a:latin typeface="Calibri"/>
+                        </a:rPr>
+                        <a:t>não</a:t>
+                      </a:r>
+                      <a:r>
+                        <a:rPr sz="1800" b="0" dirty="0">
+                          <a:latin typeface="Calibri"/>
+                        </a:rPr>
+                        <a:t> </a:t>
+                      </a:r>
+                      <a:r>
+                        <a:rPr sz="1800" b="0" dirty="0" err="1">
+                          <a:latin typeface="Calibri"/>
+                        </a:rPr>
+                        <a:t>existem</a:t>
+                      </a:r>
+                      <a:r>
+                        <a:rPr sz="1800" b="0" dirty="0">
+                          <a:latin typeface="Calibri"/>
+                        </a:rPr>
+                        <a:t> à entrada</a:t>
                       </a:r>
                     </a:p>
                   </a:txBody>
@@ -7279,86 +7596,10 @@
                   </a:ext>
                 </a:extLst>
               </a:tr>
-              <a:tr h="685800">
-                <a:tc>
-                  <a:txBody>
-                    <a:bodyPr/>
-                    <a:lstStyle/>
-                    <a:p>
-                      <a:r>
-                        <a:rPr sz="1600" b="0">
-                          <a:latin typeface="Calibri"/>
-                        </a:rPr>
-                        <a:t>Método de pagamento: fator de retenção</a:t>
-                      </a:r>
-                    </a:p>
-                  </a:txBody>
-                  <a:tcPr/>
-                </a:tc>
-                <a:tc>
-                  <a:txBody>
-                    <a:bodyPr/>
-                    <a:lstStyle/>
-                    <a:p>
-                      <a:r>
-                        <a:rPr sz="1600" b="0" dirty="0">
-                          <a:latin typeface="Calibri"/>
-                        </a:rPr>
-                        <a:t>Sem </a:t>
-                      </a:r>
-                      <a:r>
-                        <a:rPr sz="1600" b="0" dirty="0" err="1">
-                          <a:latin typeface="Calibri"/>
-                        </a:rPr>
-                        <a:t>suporte</a:t>
-                      </a:r>
-                      <a:endParaRPr sz="1600" b="0" dirty="0">
-                        <a:latin typeface="Calibri"/>
-                      </a:endParaRPr>
-                    </a:p>
-                  </a:txBody>
-                  <a:tcPr/>
-                </a:tc>
-                <a:extLst>
-                  <a:ext uri="{0D108BD9-81ED-4DB2-BD59-A6C34878D82A}">
-                    <a16:rowId xmlns:a16="http://schemas.microsoft.com/office/drawing/2014/main" val="10004"/>
-                  </a:ext>
-                </a:extLst>
-              </a:tr>
             </a:tbl>
           </a:graphicData>
         </a:graphic>
       </p:graphicFrame>
-      <p:pic>
-        <p:nvPicPr>
-          <p:cNvPr id="9" name="Picture 8" descr="figA_abandono.png">
-            <a:extLst>
-              <a:ext uri="{FF2B5EF4-FFF2-40B4-BE49-F238E27FC236}">
-                <a16:creationId xmlns:a16="http://schemas.microsoft.com/office/drawing/2014/main" id="{EE76F430-260F-A05F-7053-762B41F64F36}"/>
-              </a:ext>
-            </a:extLst>
-          </p:cNvPr>
-          <p:cNvPicPr>
-            <a:picLocks noChangeAspect="1"/>
-          </p:cNvPicPr>
-          <p:nvPr/>
-        </p:nvPicPr>
-        <p:blipFill>
-          <a:blip r:embed="rId2"/>
-          <a:stretch>
-            <a:fillRect/>
-          </a:stretch>
-        </p:blipFill>
-        <p:spPr>
-          <a:xfrm>
-            <a:off x="7315200" y="1737360"/>
-            <a:ext cx="4480560" cy="3354493"/>
-          </a:xfrm>
-          <a:prstGeom prst="rect">
-            <a:avLst/>
-          </a:prstGeom>
-        </p:spPr>
-      </p:pic>
     </p:spTree>
     <p:extLst>
       <p:ext uri="{BB962C8B-B14F-4D97-AF65-F5344CB8AC3E}">
@@ -8246,23 +8487,6 @@
 </file>
 
 <file path=customXml/item1.xml><?xml version="1.0" encoding="utf-8"?>
-<?mso-contentType ?>
-<FormTemplates xmlns="http://schemas.microsoft.com/sharepoint/v3/contenttype/forms">
-  <Display>DocumentLibraryForm</Display>
-  <Edit>DocumentLibraryForm</Edit>
-  <New>DocumentLibraryForm</New>
-</FormTemplates>
-</file>
-
-<file path=customXml/item2.xml><?xml version="1.0" encoding="utf-8"?>
-<p:properties xmlns:p="http://schemas.microsoft.com/office/2006/metadata/properties" xmlns:xsi="http://www.w3.org/2001/XMLSchema-instance" xmlns:pc="http://schemas.microsoft.com/office/infopath/2007/PartnerControls">
-  <documentManagement>
-    <_activity xmlns="bcda3a80-ef81-4a74-be8c-45f19ea20168" xsi:nil="true"/>
-  </documentManagement>
-</p:properties>
-</file>
-
-<file path=customXml/item3.xml><?xml version="1.0" encoding="utf-8"?>
 <ct:contentTypeSchema xmlns:ct="http://schemas.microsoft.com/office/2006/metadata/contentType" xmlns:ma="http://schemas.microsoft.com/office/2006/metadata/properties/metaAttributes" ct:_="" ma:_="" ma:contentTypeName="Documento" ma:contentTypeID="0x010100317E3BD292D1074E9071E5E9BD49264C" ma:contentTypeVersion="16" ma:contentTypeDescription="Criar um novo documento." ma:contentTypeScope="" ma:versionID="ee4de5e85160ea76f51476abcb83f699">
   <xsd:schema xmlns:xsd="http://www.w3.org/2001/XMLSchema" xmlns:xs="http://www.w3.org/2001/XMLSchema" xmlns:p="http://schemas.microsoft.com/office/2006/metadata/properties" xmlns:ns3="e8da368f-fdc3-40ff-b8b3-2376b894beff" xmlns:ns4="bcda3a80-ef81-4a74-be8c-45f19ea20168" targetNamespace="http://schemas.microsoft.com/office/2006/metadata/properties" ma:root="true" ma:fieldsID="a443d3b006b7f037dd33dd6bbb0660e6" ns3:_="" ns4:_="">
     <xsd:import namespace="e8da368f-fdc3-40ff-b8b3-2376b894beff"/>
@@ -8501,10 +8725,38 @@
 </ct:contentTypeSchema>
 </file>
 
+<file path=customXml/item2.xml><?xml version="1.0" encoding="utf-8"?>
+<p:properties xmlns:p="http://schemas.microsoft.com/office/2006/metadata/properties" xmlns:xsi="http://www.w3.org/2001/XMLSchema-instance" xmlns:pc="http://schemas.microsoft.com/office/infopath/2007/PartnerControls">
+  <documentManagement>
+    <_activity xmlns="bcda3a80-ef81-4a74-be8c-45f19ea20168" xsi:nil="true"/>
+  </documentManagement>
+</p:properties>
+</file>
+
+<file path=customXml/item3.xml><?xml version="1.0" encoding="utf-8"?>
+<?mso-contentType ?>
+<FormTemplates xmlns="http://schemas.microsoft.com/sharepoint/v3/contenttype/forms">
+  <Display>DocumentLibraryForm</Display>
+  <Edit>DocumentLibraryForm</Edit>
+  <New>DocumentLibraryForm</New>
+</FormTemplates>
+</file>
+
 <file path=customXml/itemProps1.xml><?xml version="1.0" encoding="utf-8"?>
-<ds:datastoreItem xmlns:ds="http://schemas.openxmlformats.org/officeDocument/2006/customXml" ds:itemID="{096705D3-AFC6-4376-BEBF-E451EBA23A9A}">
+<ds:datastoreItem xmlns:ds="http://schemas.openxmlformats.org/officeDocument/2006/customXml" ds:itemID="{99F19CD0-1AD0-4138-8386-64E1C2F80C26}">
   <ds:schemaRefs>
-    <ds:schemaRef ds:uri="http://schemas.microsoft.com/sharepoint/v3/contenttype/forms"/>
+    <ds:schemaRef ds:uri="http://schemas.microsoft.com/office/2006/metadata/contentType"/>
+    <ds:schemaRef ds:uri="http://schemas.microsoft.com/office/2006/metadata/properties/metaAttributes"/>
+    <ds:schemaRef ds:uri="http://www.w3.org/2001/XMLSchema"/>
+    <ds:schemaRef ds:uri="http://schemas.microsoft.com/office/2006/metadata/properties"/>
+    <ds:schemaRef ds:uri="e8da368f-fdc3-40ff-b8b3-2376b894beff"/>
+    <ds:schemaRef ds:uri="bcda3a80-ef81-4a74-be8c-45f19ea20168"/>
+    <ds:schemaRef ds:uri="http://schemas.microsoft.com/office/2006/documentManagement/types"/>
+    <ds:schemaRef ds:uri="http://schemas.microsoft.com/office/infopath/2007/PartnerControls"/>
+    <ds:schemaRef ds:uri="http://schemas.openxmlformats.org/package/2006/metadata/core-properties"/>
+    <ds:schemaRef ds:uri="http://purl.org/dc/elements/1.1/"/>
+    <ds:schemaRef ds:uri="http://purl.org/dc/terms/"/>
+    <ds:schemaRef ds:uri="http://schemas.microsoft.com/internal/obd"/>
   </ds:schemaRefs>
 </ds:datastoreItem>
 </file>
@@ -8527,20 +8779,9 @@
 </file>
 
 <file path=customXml/itemProps3.xml><?xml version="1.0" encoding="utf-8"?>
-<ds:datastoreItem xmlns:ds="http://schemas.openxmlformats.org/officeDocument/2006/customXml" ds:itemID="{99F19CD0-1AD0-4138-8386-64E1C2F80C26}">
+<ds:datastoreItem xmlns:ds="http://schemas.openxmlformats.org/officeDocument/2006/customXml" ds:itemID="{096705D3-AFC6-4376-BEBF-E451EBA23A9A}">
   <ds:schemaRefs>
-    <ds:schemaRef ds:uri="http://schemas.microsoft.com/office/2006/metadata/contentType"/>
-    <ds:schemaRef ds:uri="http://schemas.microsoft.com/office/2006/metadata/properties/metaAttributes"/>
-    <ds:schemaRef ds:uri="http://www.w3.org/2001/XMLSchema"/>
-    <ds:schemaRef ds:uri="http://schemas.microsoft.com/office/2006/metadata/properties"/>
-    <ds:schemaRef ds:uri="e8da368f-fdc3-40ff-b8b3-2376b894beff"/>
-    <ds:schemaRef ds:uri="bcda3a80-ef81-4a74-be8c-45f19ea20168"/>
-    <ds:schemaRef ds:uri="http://schemas.microsoft.com/office/2006/documentManagement/types"/>
-    <ds:schemaRef ds:uri="http://schemas.microsoft.com/office/infopath/2007/PartnerControls"/>
-    <ds:schemaRef ds:uri="http://schemas.openxmlformats.org/package/2006/metadata/core-properties"/>
-    <ds:schemaRef ds:uri="http://purl.org/dc/elements/1.1/"/>
-    <ds:schemaRef ds:uri="http://purl.org/dc/terms/"/>
-    <ds:schemaRef ds:uri="http://schemas.microsoft.com/internal/obd"/>
+    <ds:schemaRef ds:uri="http://schemas.microsoft.com/sharepoint/v3/contenttype/forms"/>
   </ds:schemaRefs>
 </ds:datastoreItem>
 </file>
</xml_diff>

<commit_message>
Rewrite presentation script in a natural spoken style
Co-Authored-By: Claude Sonnet 5.5 <noreply@anthropic.com>
Claude-Session: https://claude.ai/code/session_011vDQkJ6MBs5BkvEmk5HUaA
</commit_message>
<xml_diff>
--- a/trabalho_analise_dados/Apresentacao_com_notas.pptx
+++ b/trabalho_analise_dados/Apresentacao_com_notas.pptx
@@ -687,7 +687,7 @@
           <a:lstStyle/>
           <a:p>
             <a:r>
-              <a:t>[0:15–1:00] A empresa quer três coisas: conhecer o perfil dos clientes, identificar segmentos distintos e dispor de um sistema para classificar novos clientes. Antes de usar os resultados do analista, pediu uma avaliação independente. A questão central é esta: os resultados e as conclusões do R5 constituem uma base adequada para apoiar a segmentação dos clientes e a classificação de novos clientes? Adianto já a resposta: não, por ora. O R5 é um bom ponto de partida, mas só serve como hipótese de trabalho a validar.</a:t>
+              <a:t>[0:15–1:00] Vamos começar pelo problema. A empresa quer conhecer melhor os clientes, perceber que grupos existem e ter uma forma de classificar os clientes novos. Antes de usar o trabalho do analista, pediu uma opinião independente. E a pergunta é simples: este relatório dá uma base adequada para segmentar e para classificar novos clientes? Digo já a minha resposta: ainda não. É um bom ponto de partida, mas é só isso, uma hipótese de trabalho que precisa de ser validada.</a:t>
             </a:r>
           </a:p>
         </p:txBody>
@@ -779,7 +779,7 @@
           <a:lstStyle/>
           <a:p>
             <a:r>
-              <a:t>[8:15–8:50] Recomendo quatro coisas à administração. Não adotar o R5 como regra operacional, usando-o como hipótese de trabalho. Exigir as correções e análises de robustez. Encomendar um modelo para classificar novos clientes, testado em dados não usados na sua construção. E testar a retenção do cluster 3 num piloto com grupo de controlo. Em conclusão, o R5 descreve bem os clientes e mostra uma associação com o abandono, mas, na forma atual, não é uma base adequada para decidir: precisa de correções, robustez e de um modelo preditivo.</a:t>
+              <a:t>[8:15–8:50] Em resumo, o que recomendo à administração? Que não use o relatório como regra, mas como ponto de partida. Que peça as correções e uma análise de robustez. Que encomende um modelo para classificar clientes novos, testado em dados que não serviram para o construir. E que teste a retenção do terceiro grupo num piloto, com grupo de controlo. A minha conclusão é esta: o R5 descreve bem os clientes e identifica uma associação interessante com o abandono, mas, tal como está, não é uma base suficiente para decidir.</a:t>
             </a:r>
           </a:p>
         </p:txBody>
@@ -849,7 +849,7 @@
           <a:lstStyle/>
           <a:p>
             <a:r>
-              <a:t>[8:50–9:00] Muito obrigado. Fico disponível para perguntas.</a:t>
+              <a:t>[8:50–9:00] Obrigado pela atenção. Fico disponível para as vossas perguntas.</a:t>
             </a:r>
           </a:p>
         </p:txBody>
@@ -919,7 +919,7 @@
           <a:lstStyle/>
           <a:p>
             <a:r>
-              <a:t>[1:00–1:50] Avaliei o R5 segundo os três critérios do enunciado. A adequação metodológica e a qualidade da análise têm apreciação parcial: as escolhas são razoáveis e os cálculos de base coerentes, mas há um erro conceptual, uma figura inconsistente e interpretações mais fortes do que a evidência. A validade das conclusões é insuficiente: das quatro que sustentam a decisão, só uma é suportada, e falta a classificação de novos clientes. Não reproduzi a análise: recalculei os números publicados, e as verificações estão no anexo.</a:t>
+              <a:t>[1:00–1:50] Para chegar a esta resposta, olhei para o relatório segundo os três critérios do enunciado. Na parte metodológica e na qualidade da análise, a apreciação é parcial. As escolhas são razoáveis e as contas de base estão certas, mas encontrei um erro de conceito, uma figura que não bate com a tabela e algumas interpretações que vão mais longe do que os dados permitem. Nas conclusões, a apreciação é insuficiente: das quatro que sustentam a decisão, só uma está realmente suportada, e falta tratar a classificação de novos clientes. Não repeti a análise: recalculei os números publicados, e isso está no anexo.</a:t>
             </a:r>
           </a:p>
         </p:txBody>
@@ -1005,7 +1005,7 @@
           <a:lstStyle/>
           <a:p>
             <a:r>
-              <a:t>[0:00–0:15] Bom dia. Chamo-me Marco Martins e vou apresentar a avaliação crítica do relatório R5, de análise e segmentação de clientes, que fiz como consultor independente.</a:t>
+              <a:t>[0:00–0:15] Bom dia. Eu sou o Marco Martins e vou apresentar a avaliação que fiz ao relatório R5, de análise e segmentação de clientes, no papel de consultor independente.</a:t>
             </a:r>
           </a:p>
         </p:txBody>
@@ -1075,7 +1075,7 @@
           <a:lstStyle/>
           <a:p>
             <a:r>
-              <a:t>[1:50–3:15] Na adequação metodológica, quatro pontos. Primeiro, o analista eliminou 20 clientes com valores em falta. É aceitável, mas só é inofensivo se a falta for aleatória, e isso não foi testado. Pelas taxas de abandono por cluster deduz-se que nesses 20 há 6 abandonos, 30%, contra 15,7% nos restantes; com p de 0,12 não é conclusivo, mas é um alerta. Segundo, ordinais e contagens foram tratadas como contínuas. Terceiro, o erro mais claro: o relatório diz que padronizar protege o K-means dos valores extremos. Não protege. O z-score é linear, como passar de metros para centímetros: os extremos continuam a 3,7 desvios-padrão e o K-means continua sensível a eles. Quarto, quatro variáveis de valor correlacionadas, com r até 0,84, pesam mais na distância, e não há inicializações nem semente, pelo que a análise não é reprodutível.</a:t>
+              <a:t>[1:50–3:15] Na parte metodológica, quero destacar quatro coisas. A primeira são os valores em falta. O analista tirou 20 clientes da análise. Com tão poucos, é aceitável, mas só se a falta de dados for ao acaso, e isso ninguém verificou. E há um sinal de alerta: pelas taxas de abandono que o relatório dá, percebe-se que nesses 20 clientes houve 6 abandonos, ou seja, 30%, contra 15,7% nos outros. Não prova nada, pode ser acaso, mas devia ter sido investigado. A segunda é o erro mais claro. O relatório diz que padronizar as variáveis protege o K-means dos valores extremos. Isso não é verdade. Padronizar é só mudar a escala, é como passar de metros para centímetros: o cliente com o rendimento mais alto continua a ser o mais alto, e continua a puxar os grupos. E a terceira: quatro variáveis ligadas ao valor estão muito correlacionadas e acabam por pesar a dobrar, e o relatório não diz que sementes usou, por isso ninguém consegue repetir os resultados.</a:t>
             </a:r>
           </a:p>
         </p:txBody>
@@ -1145,7 +1145,7 @@
           <a:lstStyle/>
           <a:p>
             <a:r>
-              <a:t>[3:15–4:10] A silhueta é máxima com k igual a 2, 0,353, e o analista escolheu k igual a 3, 0,325, por ser mais interpretável. É legítimo e foi transparente, mas usou um só índice, sem estabilidade, e todas as silhuetas ficam entre 0,21 e 0,35, estrutura fraca. Com k igual a 4 o valor é quase igual, e a figura do relatório sugere quatro nuvens. Por isso, dizer que os segmentos são distintos é demasiado forte.</a:t>
+              <a:t>[3:15–4:10] Passemos à escolha do número de grupos. Olhando para o gráfico, a silhueta é mais alta com dois grupos, e o analista escolheu três, porque lhe pareceram mais fáceis de interpretar. Não é uma decisão errada, e o analista foi transparente. O problema é que só usou este critério, e não testou se os grupos se mantêm estáveis. E repare-se: todos os valores estão entre 0,21 e 0,35, o que, segundo a literatura, quer dizer estrutura fraca. Com quatro grupos o resultado é quase igual, e a própria figura do relatório parece mostrar quatro nuvens. Por isso, dizer que os segmentos são distintos é forte demais.</a:t>
             </a:r>
           </a:p>
         </p:txBody>
@@ -1215,7 +1215,7 @@
           <a:lstStyle/>
           <a:p>
             <a:r>
-              <a:t>[4:10–5:20] Na qualidade da análise, encontrei erros verificáveis. O V de Cramér da Região está errado: a raiz de 1,364 sobre 300 dá 0,067 e não 0,039. Os valores próprios somam 9,033 em vez de 9. As loadings são, na verdade, vetores próprios. E o cluster 3 é descrito como mais velho, mas tem 47,9 anos, como o cluster 1. O mais grave está na figura: o cluster 3, a verde, está no lado direito da primeira componente, com rendimento e despesa elevados, mas a Tabela 10 atribui esse perfil ao cluster 1. As proporções de pontos, 22, 48 e 30 por cento, indicam que as legendas dos clusters 1 e 3 estão trocadas, na figura ou na tabela. Quem lesse a figura podia dirigir a retenção ao segmento errado.</a:t>
+              <a:t>[4:10–5:20] Na qualidade da análise, encontrei erros que se confirmam com uma simples conta. O V de Cramér da região devia ser 0,067, e não 0,039. Os valores próprios somam 9,033, quando tinham de somar 9. O que o relatório chama de loadings são, na verdade, vetores próprios. E o terceiro grupo é dado como mais velho, mas tem a mesma idade do primeiro. Mas o que mais me preocupou foi a figura. Vejam: o grupo a verde está do lado direito, onde ficam os clientes com mais rendimento, mais despesa e mais visitas. Só que, na tabela, esse perfil pertence ao Cluster 1, e não ao 3. Pela proporção de pontos de cada cor, cerca de 22%, 48% e 30%, tudo indica que as legendas do 1 e do 3 estão trocadas, na figura ou na tabela. E isto importa: quem lesse a figura podia mandar as ações de retenção para o grupo errado.</a:t>
             </a:r>
           </a:p>
         </p:txBody>
@@ -1285,7 +1285,7 @@
           <a:lstStyle/>
           <a:p>
             <a:r>
-              <a:t>[5:20–6:15] Há interpretações que vão além da evidência. O valor do cliente é inferido do rendimento e da despesa, que não medem o valor para a empresa. Os clusters são descritos com as variáveis que os formaram, por isso as diferenças são grandes por construção. E o método de pagamento, com p de 0,065, não é significativo, mas é apresentado como fator relevante, enquanto a fidelização e o perfil, com p de 0,088 e 0,090, são ignorados. É uma hipótese a testar, não uma conclusão.</a:t>
+              <a:t>[5:20–6:15] Há ainda algumas interpretações que dizem mais do que os dados mostram. Por exemplo, chama-se valor do cliente ao rendimento e à despesa. Mas o rendimento de um cliente não é o valor que ele tem para a empresa, isso seria receita ou margem. Depois, os grupos são descritos com as variáveis que os criaram, por isso é natural que sejam diferentes. E o método de pagamento: o resultado não é significativo, com p de 0,065, mas o relatório sugere que pode ser um fator importante para a retenção, enquanto a fidelização e o perfil, com valores quase iguais, nem são mencionados. Para mim, isso é uma pista para investigar, não uma conclusão.</a:t>
             </a:r>
           </a:p>
         </p:txBody>
@@ -1355,7 +1355,7 @@
           <a:lstStyle/>
           <a:p>
             <a:r>
-              <a:t>[6:15–7:25] Na validade das conclusões, analisei as quatro que sustentam a decisão. Três segmentos distintos: parcialmente suportada. A única suportada é que o cluster 3 tem maior abandono, 23% contra 8,1% e 9,6%, com p de 0,0055, que confirmei. Mas é associação, não previsão: 77% do cluster 3 não abandonou, não há AUC, os intervalos de confiança sobrepõem-se um pouco, como se vê no gráfico, e não se sabe quando foram medidas as variáveis. Por isso, demonstra devia ser sugere. As outras duas, diferenças entre clusters em variáveis categóricas e método de pagamento como fator de retenção, não têm suporte.</a:t>
+              <a:t>[6:15–7:25] Vamos então às conclusões. Olhei para as quatro que sustentam a decisão. A existência de três segmentos distintos fica só parcialmente suportada, pelas razões que vimos. A única que se confirma é que o terceiro grupo abandona mais: 23%, contra cerca de 8 e 10%. Refiz o teste e confere. Mas atenção, isto é uma associação, não uma previsão. Quase 8 em cada 10 clientes desse grupo não abandonou. E os intervalos de confiança, que se veem no gráfico, sobrepõem-se um pouco. Além disso, não sabemos quando foram medidas as variáveis, e podem já refletir o abandono. Por isso, em vez de demonstra, o relatório devia dizer sugere. As outras duas conclusões, as diferenças entre grupos nas variáveis categóricas e o papel do método de pagamento, não têm suporte nos resultados.</a:t>
             </a:r>
           </a:p>
         </p:txBody>
@@ -1425,7 +1425,7 @@
           <a:lstStyle/>
           <a:p>
             <a:r>
-              <a:t>[7:25–8:15] Quanto ao problema da empresa: o perfil dos clientes, em grande parte, com reservas; os segmentos distintos, só parcialmente; e classificar novos clientes, não. Não há centróides nem parâmetros de padronização, classificador ou validação, e a eliminação de casos não se aplica a clientes novos. Além disso, as variáveis usadas, como antiguidade ou visitas, acumulam-se com o tempo e não existem à entrada: um cliente recém-chegado tenderia a parecer-se com o cluster 2 só por ser recente, o que é uma inferência minha, não um cálculo.</a:t>
+              <a:t>[7:25–8:15] Então, voltando à empresa, o que é que o relatório resolve? Perceber o perfil dos clientes: em grande parte, sim, com as reservas que já referi. Identificar segmentos distintos: só em parte. E classificar novos clientes: não. O relatório não deixa uma regra para atribuir um cliente a um grupo, não tem nenhum modelo, não testa nada em dados novos, e apagar clientes com dados em falta não é opção quando chega um cliente novo. E há uma questão de fundo: os grupos foram feitos com informação que só existe passado algum tempo, como a antiguidade ou as visitas. Um cliente que acabou de chegar ainda não a tem, e tenderia a parecer-se com o grupo dos mais recentes só por isso. Isto é um raciocínio meu, não um cálculo.</a:t>
             </a:r>
           </a:p>
         </p:txBody>

</xml_diff>

<commit_message>
Add 8-minute version of the presentation script
Co-Authored-By: Claude Sonnet 5.5 <noreply@anthropic.com>
Claude-Session: https://claude.ai/code/session_011vDQkJ6MBs5BkvEmk5HUaA
</commit_message>
<xml_diff>
--- a/trabalho_analise_dados/Apresentacao_com_notas.pptx
+++ b/trabalho_analise_dados/Apresentacao_com_notas.pptx
@@ -687,7 +687,7 @@
           <a:lstStyle/>
           <a:p>
             <a:r>
-              <a:t>[0:15–1:00] Vamos começar pelo problema. A empresa quer conhecer melhor os clientes, perceber que grupos existem e ter uma forma de classificar os clientes novos. Antes de usar o trabalho do analista, pediu uma opinião independente. E a pergunta é simples: este relatório dá uma base adequada para segmentar e para classificar novos clientes? Digo já a minha resposta: ainda não. É um bom ponto de partida, mas é só isso, uma hipótese de trabalho que precisa de ser validada.</a:t>
+              <a:t>[0:13–0:48] A empresa quer conhecer melhor a sua carteira de clientes, perceber que grupos existem e ter uma forma de classificar os clientes novos. Antes de usar o trabalho do analista, pediu uma opinião independente. A pergunta é simples: este relatório é uma base adequada para segmentar e classificar novos clientes? A minha resposta é: ainda não. É um bom ponto de partida, mas ainda só uma hipótese de trabalho a validar.</a:t>
             </a:r>
           </a:p>
         </p:txBody>
@@ -779,7 +779,7 @@
           <a:lstStyle/>
           <a:p>
             <a:r>
-              <a:t>[8:15–8:50] Em resumo, o que recomendo à administração? Que não use o relatório como regra, mas como ponto de partida. Que peça as correções e uma análise de robustez. Que encomende um modelo para classificar clientes novos, testado em dados que não serviram para o construir. E que teste a retenção do terceiro grupo num piloto, com grupo de controlo. A minha conclusão é esta: o R5 descreve bem os clientes e identifica uma associação interessante com o abandono, mas, tal como está, não é uma base suficiente para decidir.</a:t>
+              <a:t>[7:14–7:50] Em resumo, recomendo que o relatório não seja usado como regra, mas como ponto de partida. São necessárias correções e uma análise de robustez, e um modelo para classificar clientes novos, testado em dados que não serviram para o construir. E que se teste a retenção do terceiro grupo com um grupo de controlo. Conclusão: bom ponto de partida, mas ainda não uma base adequada. Precisa de correções, robustez e de um modelo preditivo.</a:t>
             </a:r>
           </a:p>
         </p:txBody>
@@ -849,7 +849,7 @@
           <a:lstStyle/>
           <a:p>
             <a:r>
-              <a:t>[8:50–9:00] Obrigado pela atenção. Fico disponível para as vossas perguntas.</a:t>
+              <a:t>[7:50–7:53] Obrigado pela atenção. Fico disponível para perguntas.</a:t>
             </a:r>
           </a:p>
         </p:txBody>
@@ -919,7 +919,7 @@
           <a:lstStyle/>
           <a:p>
             <a:r>
-              <a:t>[1:00–1:50] Para chegar a esta resposta, olhei para o relatório segundo os três critérios do enunciado. Na parte metodológica e na qualidade da análise, a apreciação é parcial. As escolhas são razoáveis e as contas de base estão certas, mas encontrei um erro de conceito, uma figura que não bate com a tabela e algumas interpretações que vão mais longe do que os dados permitem. Nas conclusões, a apreciação é insuficiente: das quatro que sustentam a decisão, só uma está realmente suportada, e falta tratar a classificação de novos clientes. Não repeti a análise: recalculei os números publicados, e isso está no anexo.</a:t>
+              <a:t>[0:48–1:35] Avaliei o relatório segundo os três critérios do enunciado. Na parte metodológica e na qualidade da análise, a apreciação é parcial: as escolhas são razoáveis e os cálculos de base estão corretos, mas encontrei um erro de conceito, uma figura que não bate com a tabela e interpretações que vão mais longe do que os dados permitem. Nas conclusões, a apreciação é insuficiente: das quatro que sustentam a decisão, só uma está suportada, e falta a classificação de novos clientes, um dos três objetivos da empresa. Não repeti a análise: apenas recalculei os números publicados, que estão em anexo.</a:t>
             </a:r>
           </a:p>
         </p:txBody>
@@ -1005,7 +1005,7 @@
           <a:lstStyle/>
           <a:p>
             <a:r>
-              <a:t>[0:00–0:15] Bom dia. Eu sou o Marco Martins e vou apresentar a avaliação que fiz ao relatório R5, de análise e segmentação de clientes, no papel de consultor independente.</a:t>
+              <a:t>[0:00–0:13] Bom dia. Eu sou o Marco Martins e vou apresentar a avaliação que fiz ao relatório R5, de análise e segmentação de clientes, no papel de consultor independente.</a:t>
             </a:r>
           </a:p>
         </p:txBody>
@@ -1075,7 +1075,7 @@
           <a:lstStyle/>
           <a:p>
             <a:r>
-              <a:t>[1:50–3:15] Na parte metodológica, quero destacar quatro coisas. A primeira são os valores em falta. O analista tirou 20 clientes da análise. Com tão poucos, é aceitável, mas só se a falta de dados for ao acaso, e isso ninguém verificou. E há um sinal de alerta: pelas taxas de abandono que o relatório dá, percebe-se que nesses 20 clientes houve 6 abandonos, ou seja, 30%, contra 15,7% nos outros. Não prova nada, pode ser acaso, mas devia ter sido investigado. A segunda é o erro mais claro. O relatório diz que padronizar as variáveis protege o K-means dos valores extremos. Isso não é verdade. Padronizar é só mudar a escala, é como passar de metros para centímetros: o cliente com o rendimento mais alto continua a ser o mais alto, e continua a puxar os grupos. E a terceira: quatro variáveis ligadas ao valor estão muito correlacionadas e acabam por pesar a dobrar, e o relatório não diz que sementes usou, por isso ninguém consegue repetir os resultados.</a:t>
+              <a:t>[1:35–2:52] Na parte metodológica, quero destacar quatro coisas. A primeira são os valores em falta. O analista eliminou 20 clientes. É aceitável, mas só se a falta de dados for ao acaso, e isso não foi verificado. E há um sinal de alerta: pelas taxas de abandono, percebe-se que nesses 20 clientes houve 6 abandonos, 30%, contra 15,7% nos restantes. Não prova nada, pode ser acaso, mas devia ter sido investigado. A segunda: variáveis ordinais e de contagem foram tratadas como contínuas. A terceira é o erro mais claro. O relatório diz que padronizar as variáveis protege o K-means dos valores extremos. Não é verdade. Padronizar é só mudar a escala, como passar de metros para centímetros: o cliente com o rendimento mais alto continua a puxar os grupos. E a quarta: quatro variáveis ligadas ao valor estão muito correlacionadas e pesam mais do que as outras, e o relatório não indica a semente usada, por isso ninguém repete os resultados.</a:t>
             </a:r>
           </a:p>
         </p:txBody>
@@ -1145,7 +1145,7 @@
           <a:lstStyle/>
           <a:p>
             <a:r>
-              <a:t>[3:15–4:10] Passemos à escolha do número de grupos. Olhando para o gráfico, a silhueta é mais alta com dois grupos, e o analista escolheu três, porque lhe pareceram mais fáceis de interpretar. Não é uma decisão errada, e o analista foi transparente. O problema é que só usou este critério, e não testou se os grupos se mantêm estáveis. E repare-se: todos os valores estão entre 0,21 e 0,35, o que, segundo a literatura, quer dizer estrutura fraca. Com quatro grupos o resultado é quase igual, e a própria figura do relatório parece mostrar quatro nuvens. Por isso, dizer que os segmentos são distintos é forte demais.</a:t>
+              <a:t>[2:52–3:34] Passemos à escolha do número de grupos. A silhueta é mais alta com dois grupos, e o analista escolheu três porque lhe pareceram mais fáceis de interpretar. Não é uma decisão errada, mas só usou este critério e não testou se os grupos são estáveis. E todos os valores estão entre 0,21 e 0,35, o que é estrutura fraca. Com quatro grupos o resultado é praticamente igual, e a figura do relatório parece mostrar quatro nuvens. Por isso, dizer que os segmentos são distintos é forte demais.</a:t>
             </a:r>
           </a:p>
         </p:txBody>
@@ -1215,7 +1215,7 @@
           <a:lstStyle/>
           <a:p>
             <a:r>
-              <a:t>[4:10–5:20] Na qualidade da análise, encontrei erros que se confirmam com uma simples conta. O V de Cramér da região devia ser 0,067, e não 0,039. Os valores próprios somam 9,033, quando tinham de somar 9. O que o relatório chama de loadings são, na verdade, vetores próprios. E o terceiro grupo é dado como mais velho, mas tem a mesma idade do primeiro. Mas o que mais me preocupou foi a figura. Vejam: o grupo a verde está do lado direito, onde ficam os clientes com mais rendimento, mais despesa e mais visitas. Só que, na tabela, esse perfil pertence ao Cluster 1, e não ao 3. Pela proporção de pontos de cada cor, cerca de 22%, 48% e 30%, tudo indica que as legendas do 1 e do 3 estão trocadas, na figura ou na tabela. E isto importa: quem lesse a figura podia mandar as ações de retenção para o grupo errado.</a:t>
+              <a:t>[3:34–4:36] Na qualidade da análise, encontrei erros que se confirmam com uma simples conta. O V de Cramér da região devia ser 0,067 e não 0,039. Os valores próprios somam 9,033 e deviam somar 9. O que o relatório chama de loadings são vetores próprios. E o terceiro grupo é dado como mais velho, mas tem a mesma idade do primeiro. O que mais me preocupou foi a figura: o grupo a verde está do lado direito, onde ficam os clientes com mais rendimento, despesa e visitas, mas na tabela esse perfil é do Cluster 1, não do 3. Pelas proporções de pontos, tudo indica que as legendas do 1 e do 3 estão trocadas, na figura ou na tabela. Quem lesse a figura podia mandar a retenção para o grupo errado.</a:t>
             </a:r>
           </a:p>
         </p:txBody>
@@ -1285,7 +1285,7 @@
           <a:lstStyle/>
           <a:p>
             <a:r>
-              <a:t>[5:20–6:15] Há ainda algumas interpretações que dizem mais do que os dados mostram. Por exemplo, chama-se valor do cliente ao rendimento e à despesa. Mas o rendimento de um cliente não é o valor que ele tem para a empresa, isso seria receita ou margem. Depois, os grupos são descritos com as variáveis que os criaram, por isso é natural que sejam diferentes. E o método de pagamento: o resultado não é significativo, com p de 0,065, mas o relatório sugere que pode ser um fator importante para a retenção, enquanto a fidelização e o perfil, com valores quase iguais, nem são mencionados. Para mim, isso é uma pista para investigar, não uma conclusão.</a:t>
+              <a:t>[4:36–5:23] Há ainda interpretações que dizem mais do que os dados mostram. Chama-se valor do cliente ao rendimento e à despesa, mas isso não é o valor para a empresa, que seria receita ou margem. Os grupos são descritos com as variáveis que os criaram, por isso é natural que sejam diferentes. E o método de pagamento não é significativo, com p de 0,065, mas o relatório sugere que pode ser um fator importante para a retenção, enquanto a fidelização e o perfil, com valores quase iguais, nem são mencionados. É uma pista a investigar, não uma conclusão.</a:t>
             </a:r>
           </a:p>
         </p:txBody>
@@ -1355,7 +1355,7 @@
           <a:lstStyle/>
           <a:p>
             <a:r>
-              <a:t>[6:15–7:25] Vamos então às conclusões. Olhei para as quatro que sustentam a decisão. A existência de três segmentos distintos fica só parcialmente suportada, pelas razões que vimos. A única que se confirma é que o terceiro grupo abandona mais: 23%, contra cerca de 8 e 10%. Refiz o teste e confere. Mas atenção, isto é uma associação, não uma previsão. Quase 8 em cada 10 clientes desse grupo não abandonou. E os intervalos de confiança, que se veem no gráfico, sobrepõem-se um pouco. Além disso, não sabemos quando foram medidas as variáveis, e podem já refletir o abandono. Por isso, em vez de demonstra, o relatório devia dizer sugere. As outras duas conclusões, as diferenças entre grupos nas variáveis categóricas e o papel do método de pagamento, não têm suporte nos resultados.</a:t>
+              <a:t>[5:23–6:17] Quanto às conclusões, olhei para as quatro que sustentam a decisão. Os três segmentos distintos ficam só parcialmente suportados, pelas razões que vimos. A única que se confirma é que o terceiro grupo abandona mais: 23%, contra cerca de 8 e 10%. Refiz o teste e confere. Mas é uma associação, não uma previsão: quase 8 em cada 10 clientes desse grupo não abandonou, e os intervalos de confiança sobrepõem-se ligeiramente. Também não sabemos quando foram medidas as variáveis, e podem já refletir o abandono. Por isso, em vez de demonstra, o relatório devia dizer sugere. As outras duas, as diferenças em variáveis categóricas e o método de pagamento, não têm suporte.</a:t>
             </a:r>
           </a:p>
         </p:txBody>
@@ -1425,7 +1425,7 @@
           <a:lstStyle/>
           <a:p>
             <a:r>
-              <a:t>[7:25–8:15] Então, voltando à empresa, o que é que o relatório resolve? Perceber o perfil dos clientes: em grande parte, sim, com as reservas que já referi. Identificar segmentos distintos: só em parte. E classificar novos clientes: não. O relatório não deixa uma regra para atribuir um cliente a um grupo, não tem nenhum modelo, não testa nada em dados novos, e apagar clientes com dados em falta não é opção quando chega um cliente novo. E há uma questão de fundo: os grupos foram feitos com informação que só existe passado algum tempo, como a antiguidade ou as visitas. Um cliente que acabou de chegar ainda não a tem, e tenderia a parecer-se com o grupo dos mais recentes só por isso. Isto é um raciocínio meu, não um cálculo.</a:t>
+              <a:t>[6:17–7:14] Voltando ao que a empresa pede: perceber o perfil dos clientes, em grande parte sim, com as reservas já referidas; identificar segmentos distintos, só em parte. E classificar novos clientes: não. O relatório não deixa uma regra para atribuir um cliente a um grupo, não tem nenhum modelo, não testa nada em dados novos, e apagar clientes com dados em falta não é opção quando chega um cliente novo. E há uma questão de fundo: os grupos foram feitos com informação que só existe passado algum tempo, como a antiguidade ou as visitas. Um cliente recém-chegado ainda não a tem, e tenderia a parecer-se com o grupo dos mais recentes só por isso. É um raciocínio meu, não um cálculo.</a:t>
             </a:r>
           </a:p>
         </p:txBody>

</xml_diff>